<commit_message>
PowerPoint-Import: Format einzelner Zeilen, Wörter und Tabellenzellen bleibt erhalten
Bisher bekam ein Textfeld nur ein Format (das vorherrschende), Tabellen nur Text.
Neu speichern Text, Notiz und Form Stellen mit eigenem Format als «laeufe», Tabellen
das Format jeder Zelle als «stile» (auch aus dem Tabellenstil von PowerPoint, mit
Streifen und Kopfzeile). Anzeige, Präsentieren, HTML- und PowerPoint-Export nutzen
das Format; beim Weiterschreiben bleibt es erhalten, der Format-Dialog gilt für alle.

Co-Authored-By: Claude Opus 5.5 <noreply@anthropic.com>
</commit_message>
<xml_diff>
--- a/tools/testdaten/beispiel.pptx
+++ b/tools/testdaten/beispiel.pptx
@@ -4058,11 +4058,16 @@
                     <a:lstStyle/>
                     <a:p>
                       <a:r>
+                        <a:rPr b="1"/>
                         <a:t>2100 h</a:t>
                       </a:r>
                     </a:p>
                   </a:txBody>
-                  <a:tcPr/>
+                  <a:tcPr>
+                    <a:solidFill>
+                      <a:srgbClr val="FFE082"/>
+                    </a:solidFill>
+                  </a:tcPr>
                 </a:tc>
               </a:tr>
             </a:tbl>
@@ -4224,7 +4229,7 @@
         <p:spPr>
           <a:xfrm>
             <a:off x="457200" y="365760"/>
-            <a:ext cx="8229600" cy="1097280"/>
+            <a:ext cx="8229600" cy="1463040"/>
           </a:xfrm>
           <a:prstGeom prst="rect">
             <a:avLst/>
@@ -4245,6 +4250,26 @@
                 <a:latin typeface="Georgia"/>
               </a:rPr>
               <a:t>Zusatz für Schnelle</a:t>
+            </a:r>
+          </a:p>
+          <a:p>
+            <a:r>
+              <a:rPr sz="2000" b="0">
+                <a:solidFill>
+                  <a:srgbClr val="1F2933"/>
+                </a:solidFill>
+                <a:latin typeface="Georgia"/>
+              </a:rPr>
+              <a:t>nur </a:t>
+            </a:r>
+            <a:r>
+              <a:rPr sz="2000" b="0">
+                <a:solidFill>
+                  <a:srgbClr val="065A82"/>
+                </a:solidFill>
+                <a:latin typeface="Georgia"/>
+              </a:rPr>
+              <a:t>kurz</a:t>
             </a:r>
           </a:p>
         </p:txBody>

</xml_diff>

<commit_message>
Runde Ecken auch bei breiten Formen, Text wird nicht mehr abgeschnitten
Abgerundete Rechtecke hatten bei breiten Formen gestreckte Ecken, weil die Rundung
ein Anteil der Breite war. Jetzt ist sie ein Anteil der kürzeren Seite wie in
PowerPoint (`rundung`, beim Import aus adj, Standard 1/6), auch beim Export.
Text in knappen Textfeldern und Formen läuft wie in PowerPoint über den Rand,
statt abgeschnitten zu werden.

Co-Authored-By: Claude Opus 5.5 <noreply@anthropic.com>
</commit_message>
<xml_diff>
--- a/tools/testdaten/beispiel.pptx
+++ b/tools/testdaten/beispiel.pptx
@@ -4274,9 +4274,78 @@
           </a:p>
         </p:txBody>
       </p:sp>
+      <p:sp>
+        <p:nvSpPr>
+          <p:cNvPr id="3" name="Rounded Rectangle 2"/>
+          <p:cNvSpPr/>
+          <p:nvPr/>
+        </p:nvSpPr>
+        <p:spPr>
+          <a:xfrm>
+            <a:off x="457200" y="4937760"/>
+            <a:ext cx="8229600" cy="1645920"/>
+          </a:xfrm>
+          <a:prstGeom prst="roundRect">
+            <a:avLst/>
+          </a:prstGeom>
+          <a:solidFill>
+            <a:srgbClr val="FDFBF7"/>
+          </a:solidFill>
+        </p:spPr>
+        <p:style>
+          <a:lnRef idx="1">
+            <a:schemeClr val="accent1"/>
+          </a:lnRef>
+          <a:fillRef idx="3">
+            <a:schemeClr val="accent1"/>
+          </a:fillRef>
+          <a:effectRef idx="2">
+            <a:schemeClr val="accent1"/>
+          </a:effectRef>
+          <a:fontRef idx="minor">
+            <a:schemeClr val="lt1"/>
+          </a:fontRef>
+        </p:style>
+        <p:txBody>
+          <a:bodyPr rtlCol="0" anchor="ctr"/>
+          <a:lstStyle/>
+          <a:p>
+            <a:pPr algn="ctr"/>
+          </a:p>
+        </p:txBody>
+      </p:sp>
+      <p:sp>
+        <p:nvSpPr>
+          <p:cNvPr id="4" name="TextBox 3"/>
+          <p:cNvSpPr txBox="1"/>
+          <p:nvPr/>
+        </p:nvSpPr>
+        <p:spPr>
+          <a:xfrm>
+            <a:off x="731520" y="5029200"/>
+            <a:ext cx="2743200" cy="274320"/>
+          </a:xfrm>
+          <a:prstGeom prst="rect">
+            <a:avLst/>
+          </a:prstGeom>
+          <a:noFill/>
+        </p:spPr>
+        <p:txBody>
+          <a:bodyPr wrap="none">
+            <a:spAutoFit/>
+          </a:bodyPr>
+          <a:lstStyle/>
+          <a:p>
+            <a:r>
+              <a:rPr sz="2800"/>
+              <a:t>Auftrag</a:t>
+            </a:r>
+          </a:p>
+        </p:txBody>
+      </p:sp>
       <p:graphicFrame>
         <p:nvGraphicFramePr>
-          <p:cNvPr id="3" name="Chart 2"/>
+          <p:cNvPr id="5" name="Chart 4"/>
           <p:cNvGraphicFramePr>
             <a:graphicFrameLocks noGrp="1"/>
           </p:cNvGraphicFramePr>
@@ -4294,7 +4363,7 @@
       </p:graphicFrame>
       <p:pic>
         <p:nvPicPr>
-          <p:cNvPr id="4" name="movie.mp4">
+          <p:cNvPr id="6" name="movie.mp4">
             <a:hlinkClick r:id="" action="ppaction://media"/>
           </p:cNvPr>
           <p:cNvPicPr>
@@ -4343,7 +4412,7 @@
                   </p:stCondLst>
                 </p:cTn>
                 <p:tgtEl>
-                  <p:spTgt spid="4"/>
+                  <p:spTgt spid="6"/>
                 </p:tgtEl>
               </p:cMediaNode>
             </p:video>

</xml_diff>